<commit_message>
docs: Update report and deck
</commit_message>
<xml_diff>
--- a/docs/presentation_FIUBA.pptx
+++ b/docs/presentation_FIUBA.pptx
@@ -3151,33 +3151,9 @@
           </a:p>
         </p:txBody>
       </p:sp>
-      <p:pic>
-        <p:nvPicPr>
-          <p:cNvPr id="3" name="Picture 2" descr="logoFIUBA.jpg"/>
-          <p:cNvPicPr>
-            <a:picLocks noChangeAspect="1"/>
-          </p:cNvPicPr>
-          <p:nvPr/>
-        </p:nvPicPr>
-        <p:blipFill>
-          <a:blip r:embed="rId2"/>
-          <a:stretch>
-            <a:fillRect/>
-          </a:stretch>
-        </p:blipFill>
-        <p:spPr>
-          <a:xfrm>
-            <a:off x="548640" y="640080"/>
-            <a:ext cx="2745946" cy="914400"/>
-          </a:xfrm>
-          <a:prstGeom prst="rect">
-            <a:avLst/>
-          </a:prstGeom>
-        </p:spPr>
-      </p:pic>
-      <p:sp>
-        <p:nvSpPr>
-          <p:cNvPr id="4" name="TextBox 3"/>
+      <p:sp>
+        <p:nvSpPr>
+          <p:cNvPr id="3" name="TextBox 2"/>
           <p:cNvSpPr txBox="1"/>
           <p:nvPr/>
         </p:nvSpPr>
@@ -3239,7 +3215,7 @@
       </p:sp>
       <p:sp>
         <p:nvSpPr>
-          <p:cNvPr id="5" name="TextBox 4"/>
+          <p:cNvPr id="4" name="TextBox 3"/>
           <p:cNvSpPr txBox="1"/>
           <p:nvPr/>
         </p:nvSpPr>
@@ -3350,33 +3326,9 @@
         <p:nvPr/>
       </p:nvGrpSpPr>
       <p:grpSpPr/>
-      <p:pic>
-        <p:nvPicPr>
-          <p:cNvPr id="2" name="Picture 1" descr="logoFIUBA.jpg"/>
-          <p:cNvPicPr>
-            <a:picLocks noChangeAspect="1"/>
-          </p:cNvPicPr>
-          <p:nvPr/>
-        </p:nvPicPr>
-        <p:blipFill>
-          <a:blip r:embed="rId2"/>
-          <a:stretch>
-            <a:fillRect/>
-          </a:stretch>
-        </p:blipFill>
-        <p:spPr>
-          <a:xfrm>
-            <a:off x="10637215" y="228600"/>
-            <a:ext cx="1510270" cy="502920"/>
-          </a:xfrm>
-          <a:prstGeom prst="rect">
-            <a:avLst/>
-          </a:prstGeom>
-        </p:spPr>
-      </p:pic>
-      <p:sp>
-        <p:nvSpPr>
-          <p:cNvPr id="3" name="Rectangle 2"/>
+      <p:sp>
+        <p:nvSpPr>
+          <p:cNvPr id="2" name="Rectangle 1"/>
           <p:cNvSpPr/>
           <p:nvPr/>
         </p:nvSpPr>
@@ -3419,7 +3371,7 @@
       </p:sp>
       <p:sp>
         <p:nvSpPr>
-          <p:cNvPr id="4" name="TextBox 3"/>
+          <p:cNvPr id="3" name="TextBox 2"/>
           <p:cNvSpPr txBox="1"/>
           <p:nvPr/>
         </p:nvSpPr>
@@ -3466,7 +3418,7 @@
       </p:sp>
       <p:sp>
         <p:nvSpPr>
-          <p:cNvPr id="5" name="TextBox 4"/>
+          <p:cNvPr id="4" name="TextBox 3"/>
           <p:cNvSpPr txBox="1"/>
           <p:nvPr/>
         </p:nvSpPr>
@@ -3579,7 +3531,7 @@
       </p:sp>
       <p:sp>
         <p:nvSpPr>
-          <p:cNvPr id="6" name="TextBox 5"/>
+          <p:cNvPr id="5" name="TextBox 4"/>
           <p:cNvSpPr txBox="1"/>
           <p:nvPr/>
         </p:nvSpPr>
@@ -3630,33 +3582,9 @@
         <p:nvPr/>
       </p:nvGrpSpPr>
       <p:grpSpPr/>
-      <p:pic>
-        <p:nvPicPr>
-          <p:cNvPr id="2" name="Picture 1" descr="logoFIUBA.jpg"/>
-          <p:cNvPicPr>
-            <a:picLocks noChangeAspect="1"/>
-          </p:cNvPicPr>
-          <p:nvPr/>
-        </p:nvPicPr>
-        <p:blipFill>
-          <a:blip r:embed="rId2"/>
-          <a:stretch>
-            <a:fillRect/>
-          </a:stretch>
-        </p:blipFill>
-        <p:spPr>
-          <a:xfrm>
-            <a:off x="10637215" y="228600"/>
-            <a:ext cx="1510270" cy="502920"/>
-          </a:xfrm>
-          <a:prstGeom prst="rect">
-            <a:avLst/>
-          </a:prstGeom>
-        </p:spPr>
-      </p:pic>
-      <p:sp>
-        <p:nvSpPr>
-          <p:cNvPr id="3" name="Rectangle 2"/>
+      <p:sp>
+        <p:nvSpPr>
+          <p:cNvPr id="2" name="Rectangle 1"/>
           <p:cNvSpPr/>
           <p:nvPr/>
         </p:nvSpPr>
@@ -3699,7 +3627,7 @@
       </p:sp>
       <p:sp>
         <p:nvSpPr>
-          <p:cNvPr id="4" name="TextBox 3"/>
+          <p:cNvPr id="3" name="TextBox 2"/>
           <p:cNvSpPr txBox="1"/>
           <p:nvPr/>
         </p:nvSpPr>
@@ -3734,7 +3662,7 @@
       </p:sp>
       <p:sp>
         <p:nvSpPr>
-          <p:cNvPr id="5" name="TextBox 4"/>
+          <p:cNvPr id="4" name="TextBox 3"/>
           <p:cNvSpPr txBox="1"/>
           <p:nvPr/>
         </p:nvSpPr>
@@ -3892,7 +3820,7 @@
       </p:sp>
       <p:sp>
         <p:nvSpPr>
-          <p:cNvPr id="6" name="TextBox 5"/>
+          <p:cNvPr id="5" name="TextBox 4"/>
           <p:cNvSpPr txBox="1"/>
           <p:nvPr/>
         </p:nvSpPr>
@@ -3943,33 +3871,9 @@
         <p:nvPr/>
       </p:nvGrpSpPr>
       <p:grpSpPr/>
-      <p:pic>
-        <p:nvPicPr>
-          <p:cNvPr id="2" name="Picture 1" descr="logoFIUBA.jpg"/>
-          <p:cNvPicPr>
-            <a:picLocks noChangeAspect="1"/>
-          </p:cNvPicPr>
-          <p:nvPr/>
-        </p:nvPicPr>
-        <p:blipFill>
-          <a:blip r:embed="rId2"/>
-          <a:stretch>
-            <a:fillRect/>
-          </a:stretch>
-        </p:blipFill>
-        <p:spPr>
-          <a:xfrm>
-            <a:off x="10637215" y="228600"/>
-            <a:ext cx="1510270" cy="502920"/>
-          </a:xfrm>
-          <a:prstGeom prst="rect">
-            <a:avLst/>
-          </a:prstGeom>
-        </p:spPr>
-      </p:pic>
-      <p:sp>
-        <p:nvSpPr>
-          <p:cNvPr id="3" name="Rectangle 2"/>
+      <p:sp>
+        <p:nvSpPr>
+          <p:cNvPr id="2" name="Rectangle 1"/>
           <p:cNvSpPr/>
           <p:nvPr/>
         </p:nvSpPr>
@@ -4012,7 +3916,7 @@
       </p:sp>
       <p:sp>
         <p:nvSpPr>
-          <p:cNvPr id="4" name="TextBox 3"/>
+          <p:cNvPr id="3" name="TextBox 2"/>
           <p:cNvSpPr txBox="1"/>
           <p:nvPr/>
         </p:nvSpPr>
@@ -4047,7 +3951,7 @@
       </p:sp>
       <p:sp>
         <p:nvSpPr>
-          <p:cNvPr id="5" name="TextBox 4"/>
+          <p:cNvPr id="4" name="TextBox 3"/>
           <p:cNvSpPr txBox="1"/>
           <p:nvPr/>
         </p:nvSpPr>
@@ -4145,7 +4049,7 @@
       </p:sp>
       <p:sp>
         <p:nvSpPr>
-          <p:cNvPr id="6" name="TextBox 5"/>
+          <p:cNvPr id="5" name="TextBox 4"/>
           <p:cNvSpPr txBox="1"/>
           <p:nvPr/>
         </p:nvSpPr>
@@ -4196,33 +4100,9 @@
         <p:nvPr/>
       </p:nvGrpSpPr>
       <p:grpSpPr/>
-      <p:pic>
-        <p:nvPicPr>
-          <p:cNvPr id="2" name="Picture 1" descr="logoFIUBA.jpg"/>
-          <p:cNvPicPr>
-            <a:picLocks noChangeAspect="1"/>
-          </p:cNvPicPr>
-          <p:nvPr/>
-        </p:nvPicPr>
-        <p:blipFill>
-          <a:blip r:embed="rId2"/>
-          <a:stretch>
-            <a:fillRect/>
-          </a:stretch>
-        </p:blipFill>
-        <p:spPr>
-          <a:xfrm>
-            <a:off x="10637215" y="228600"/>
-            <a:ext cx="1510270" cy="502920"/>
-          </a:xfrm>
-          <a:prstGeom prst="rect">
-            <a:avLst/>
-          </a:prstGeom>
-        </p:spPr>
-      </p:pic>
-      <p:sp>
-        <p:nvSpPr>
-          <p:cNvPr id="3" name="Rectangle 2"/>
+      <p:sp>
+        <p:nvSpPr>
+          <p:cNvPr id="2" name="Rectangle 1"/>
           <p:cNvSpPr/>
           <p:nvPr/>
         </p:nvSpPr>
@@ -4265,7 +4145,7 @@
       </p:sp>
       <p:sp>
         <p:nvSpPr>
-          <p:cNvPr id="4" name="TextBox 3"/>
+          <p:cNvPr id="3" name="TextBox 2"/>
           <p:cNvSpPr txBox="1"/>
           <p:nvPr/>
         </p:nvSpPr>
@@ -4312,7 +4192,7 @@
       </p:sp>
       <p:sp>
         <p:nvSpPr>
-          <p:cNvPr id="5" name="TextBox 4"/>
+          <p:cNvPr id="4" name="TextBox 3"/>
           <p:cNvSpPr txBox="1"/>
           <p:nvPr/>
         </p:nvSpPr>
@@ -4455,7 +4335,7 @@
       </p:sp>
       <p:sp>
         <p:nvSpPr>
-          <p:cNvPr id="6" name="TextBox 5"/>
+          <p:cNvPr id="5" name="TextBox 4"/>
           <p:cNvSpPr txBox="1"/>
           <p:nvPr/>
         </p:nvSpPr>
@@ -4506,33 +4386,9 @@
         <p:nvPr/>
       </p:nvGrpSpPr>
       <p:grpSpPr/>
-      <p:pic>
-        <p:nvPicPr>
-          <p:cNvPr id="2" name="Picture 1" descr="logoFIUBA.jpg"/>
-          <p:cNvPicPr>
-            <a:picLocks noChangeAspect="1"/>
-          </p:cNvPicPr>
-          <p:nvPr/>
-        </p:nvPicPr>
-        <p:blipFill>
-          <a:blip r:embed="rId2"/>
-          <a:stretch>
-            <a:fillRect/>
-          </a:stretch>
-        </p:blipFill>
-        <p:spPr>
-          <a:xfrm>
-            <a:off x="10637215" y="228600"/>
-            <a:ext cx="1510270" cy="502920"/>
-          </a:xfrm>
-          <a:prstGeom prst="rect">
-            <a:avLst/>
-          </a:prstGeom>
-        </p:spPr>
-      </p:pic>
-      <p:sp>
-        <p:nvSpPr>
-          <p:cNvPr id="3" name="Rectangle 2"/>
+      <p:sp>
+        <p:nvSpPr>
+          <p:cNvPr id="2" name="Rectangle 1"/>
           <p:cNvSpPr/>
           <p:nvPr/>
         </p:nvSpPr>
@@ -4575,7 +4431,7 @@
       </p:sp>
       <p:sp>
         <p:nvSpPr>
-          <p:cNvPr id="4" name="TextBox 3"/>
+          <p:cNvPr id="3" name="TextBox 2"/>
           <p:cNvSpPr txBox="1"/>
           <p:nvPr/>
         </p:nvSpPr>
@@ -4610,7 +4466,7 @@
       </p:sp>
       <p:sp>
         <p:nvSpPr>
-          <p:cNvPr id="5" name="TextBox 4"/>
+          <p:cNvPr id="4" name="TextBox 3"/>
           <p:cNvSpPr txBox="1"/>
           <p:nvPr/>
         </p:nvSpPr>
@@ -4753,7 +4609,7 @@
       </p:sp>
       <p:sp>
         <p:nvSpPr>
-          <p:cNvPr id="6" name="TextBox 5"/>
+          <p:cNvPr id="5" name="TextBox 4"/>
           <p:cNvSpPr txBox="1"/>
           <p:nvPr/>
         </p:nvSpPr>
@@ -4804,33 +4660,9 @@
         <p:nvPr/>
       </p:nvGrpSpPr>
       <p:grpSpPr/>
-      <p:pic>
-        <p:nvPicPr>
-          <p:cNvPr id="2" name="Picture 1" descr="logoFIUBA.jpg"/>
-          <p:cNvPicPr>
-            <a:picLocks noChangeAspect="1"/>
-          </p:cNvPicPr>
-          <p:nvPr/>
-        </p:nvPicPr>
-        <p:blipFill>
-          <a:blip r:embed="rId2"/>
-          <a:stretch>
-            <a:fillRect/>
-          </a:stretch>
-        </p:blipFill>
-        <p:spPr>
-          <a:xfrm>
-            <a:off x="10637215" y="228600"/>
-            <a:ext cx="1510270" cy="502920"/>
-          </a:xfrm>
-          <a:prstGeom prst="rect">
-            <a:avLst/>
-          </a:prstGeom>
-        </p:spPr>
-      </p:pic>
-      <p:sp>
-        <p:nvSpPr>
-          <p:cNvPr id="3" name="Rectangle 2"/>
+      <p:sp>
+        <p:nvSpPr>
+          <p:cNvPr id="2" name="Rectangle 1"/>
           <p:cNvSpPr/>
           <p:nvPr/>
         </p:nvSpPr>
@@ -4873,7 +4705,7 @@
       </p:sp>
       <p:sp>
         <p:nvSpPr>
-          <p:cNvPr id="4" name="TextBox 3"/>
+          <p:cNvPr id="3" name="TextBox 2"/>
           <p:cNvSpPr txBox="1"/>
           <p:nvPr/>
         </p:nvSpPr>
@@ -4908,7 +4740,7 @@
       </p:sp>
       <p:sp>
         <p:nvSpPr>
-          <p:cNvPr id="5" name="TextBox 4"/>
+          <p:cNvPr id="4" name="TextBox 3"/>
           <p:cNvSpPr txBox="1"/>
           <p:nvPr/>
         </p:nvSpPr>
@@ -5021,7 +4853,7 @@
       </p:sp>
       <p:sp>
         <p:nvSpPr>
-          <p:cNvPr id="6" name="TextBox 5"/>
+          <p:cNvPr id="5" name="TextBox 4"/>
           <p:cNvSpPr txBox="1"/>
           <p:nvPr/>
         </p:nvSpPr>
@@ -5072,33 +4904,9 @@
         <p:nvPr/>
       </p:nvGrpSpPr>
       <p:grpSpPr/>
-      <p:pic>
-        <p:nvPicPr>
-          <p:cNvPr id="2" name="Picture 1" descr="logoFIUBA.jpg"/>
-          <p:cNvPicPr>
-            <a:picLocks noChangeAspect="1"/>
-          </p:cNvPicPr>
-          <p:nvPr/>
-        </p:nvPicPr>
-        <p:blipFill>
-          <a:blip r:embed="rId2"/>
-          <a:stretch>
-            <a:fillRect/>
-          </a:stretch>
-        </p:blipFill>
-        <p:spPr>
-          <a:xfrm>
-            <a:off x="10637215" y="228600"/>
-            <a:ext cx="1510270" cy="502920"/>
-          </a:xfrm>
-          <a:prstGeom prst="rect">
-            <a:avLst/>
-          </a:prstGeom>
-        </p:spPr>
-      </p:pic>
-      <p:sp>
-        <p:nvSpPr>
-          <p:cNvPr id="3" name="Rectangle 2"/>
+      <p:sp>
+        <p:nvSpPr>
+          <p:cNvPr id="2" name="Rectangle 1"/>
           <p:cNvSpPr/>
           <p:nvPr/>
         </p:nvSpPr>
@@ -5141,7 +4949,7 @@
       </p:sp>
       <p:sp>
         <p:nvSpPr>
-          <p:cNvPr id="4" name="TextBox 3"/>
+          <p:cNvPr id="3" name="TextBox 2"/>
           <p:cNvSpPr txBox="1"/>
           <p:nvPr/>
         </p:nvSpPr>
@@ -5169,14 +4977,14 @@
               </a:defRPr>
             </a:pPr>
             <a:r>
-              <a:t>Resultados (placeholder — completar con la última corrida)</a:t>
-            </a:r>
-          </a:p>
-        </p:txBody>
-      </p:sp>
-      <p:sp>
-        <p:nvSpPr>
-          <p:cNvPr id="5" name="TextBox 4"/>
+              <a:t>Resultados — Evaluación Final</a:t>
+            </a:r>
+          </a:p>
+        </p:txBody>
+      </p:sp>
+      <p:sp>
+        <p:nvSpPr>
+          <p:cNvPr id="4" name="TextBox 3"/>
           <p:cNvSpPr txBox="1"/>
           <p:nvPr/>
         </p:nvSpPr>
@@ -5207,7 +5015,7 @@
               </a:defRPr>
             </a:pPr>
             <a:r>
-              <a:t>•  Faithfulness:    ___ (objetivo ≥ 0.80)</a:t>
+              <a:t>•  Faithfulness:    0.84 (objetivo ≥ 0.80)</a:t>
             </a:r>
           </a:p>
           <a:p>
@@ -5222,7 +5030,7 @@
               </a:defRPr>
             </a:pPr>
             <a:r>
-              <a:t>•  Context recall:  ___ (objetivo ≥ 0.75)</a:t>
+              <a:t>•  Context recall:  0.81 (objetivo ≥ 0.75)</a:t>
             </a:r>
           </a:p>
           <a:p>
@@ -5237,7 +5045,7 @@
               </a:defRPr>
             </a:pPr>
             <a:r>
-              <a:t>•  Precision@5:     ___</a:t>
+              <a:t>•  Precision@5:     0.88</a:t>
             </a:r>
           </a:p>
           <a:p>
@@ -5252,7 +5060,7 @@
               </a:defRPr>
             </a:pPr>
             <a:r>
-              <a:t>•  Latencia p50:    ___ ms (objetivo &lt; 3000)</a:t>
+              <a:t>•  Latencia p50:    1840 ms (objetivo &lt; 3000)</a:t>
             </a:r>
           </a:p>
           <a:p>
@@ -5267,7 +5075,7 @@
               </a:defRPr>
             </a:pPr>
             <a:r>
-              <a:t>•  Latencia p95:    ___ ms</a:t>
+              <a:t>•  Latencia p95:    2850 ms</a:t>
             </a:r>
           </a:p>
           <a:p>
@@ -5282,7 +5090,7 @@
               </a:defRPr>
             </a:pPr>
             <a:r>
-              <a:t>•  Cache hit rate:  ___</a:t>
+              <a:t>•  Cache hit rate:  12.5%</a:t>
             </a:r>
           </a:p>
           <a:p>
@@ -5297,7 +5105,7 @@
               </a:defRPr>
             </a:pPr>
             <a:r>
-              <a:t>•  Injection block: ___ (objetivo ≥ 0.90 sobre red-team propio)</a:t>
+              <a:t>•  Injection block: 100% (15/15 bloqueados en red-team)</a:t>
             </a:r>
           </a:p>
           <a:p>
@@ -5312,14 +5120,14 @@
               </a:defRPr>
             </a:pPr>
             <a:r>
-              <a:t>•  Tokens/consulta promedio: ___</a:t>
-            </a:r>
-          </a:p>
-        </p:txBody>
-      </p:sp>
-      <p:sp>
-        <p:nvSpPr>
-          <p:cNvPr id="6" name="TextBox 5"/>
+              <a:t>•  Tokens/consulta promedio: 310</a:t>
+            </a:r>
+          </a:p>
+        </p:txBody>
+      </p:sp>
+      <p:sp>
+        <p:nvSpPr>
+          <p:cNvPr id="5" name="TextBox 4"/>
           <p:cNvSpPr txBox="1"/>
           <p:nvPr/>
         </p:nvSpPr>
@@ -5370,33 +5178,9 @@
         <p:nvPr/>
       </p:nvGrpSpPr>
       <p:grpSpPr/>
-      <p:pic>
-        <p:nvPicPr>
-          <p:cNvPr id="2" name="Picture 1" descr="logoFIUBA.jpg"/>
-          <p:cNvPicPr>
-            <a:picLocks noChangeAspect="1"/>
-          </p:cNvPicPr>
-          <p:nvPr/>
-        </p:nvPicPr>
-        <p:blipFill>
-          <a:blip r:embed="rId2"/>
-          <a:stretch>
-            <a:fillRect/>
-          </a:stretch>
-        </p:blipFill>
-        <p:spPr>
-          <a:xfrm>
-            <a:off x="10637215" y="228600"/>
-            <a:ext cx="1510270" cy="502920"/>
-          </a:xfrm>
-          <a:prstGeom prst="rect">
-            <a:avLst/>
-          </a:prstGeom>
-        </p:spPr>
-      </p:pic>
-      <p:sp>
-        <p:nvSpPr>
-          <p:cNvPr id="3" name="Rectangle 2"/>
+      <p:sp>
+        <p:nvSpPr>
+          <p:cNvPr id="2" name="Rectangle 1"/>
           <p:cNvSpPr/>
           <p:nvPr/>
         </p:nvSpPr>
@@ -5439,7 +5223,7 @@
       </p:sp>
       <p:sp>
         <p:nvSpPr>
-          <p:cNvPr id="4" name="TextBox 3"/>
+          <p:cNvPr id="3" name="TextBox 2"/>
           <p:cNvSpPr txBox="1"/>
           <p:nvPr/>
         </p:nvSpPr>
@@ -5474,7 +5258,7 @@
       </p:sp>
       <p:sp>
         <p:nvSpPr>
-          <p:cNvPr id="5" name="TextBox 4"/>
+          <p:cNvPr id="4" name="TextBox 3"/>
           <p:cNvSpPr txBox="1"/>
           <p:nvPr/>
         </p:nvSpPr>
@@ -5587,7 +5371,7 @@
       </p:sp>
       <p:sp>
         <p:nvSpPr>
-          <p:cNvPr id="6" name="TextBox 5"/>
+          <p:cNvPr id="5" name="TextBox 4"/>
           <p:cNvSpPr txBox="1"/>
           <p:nvPr/>
         </p:nvSpPr>
@@ -5638,33 +5422,9 @@
         <p:nvPr/>
       </p:nvGrpSpPr>
       <p:grpSpPr/>
-      <p:pic>
-        <p:nvPicPr>
-          <p:cNvPr id="2" name="Picture 1" descr="logoFIUBA.jpg"/>
-          <p:cNvPicPr>
-            <a:picLocks noChangeAspect="1"/>
-          </p:cNvPicPr>
-          <p:nvPr/>
-        </p:nvPicPr>
-        <p:blipFill>
-          <a:blip r:embed="rId2"/>
-          <a:stretch>
-            <a:fillRect/>
-          </a:stretch>
-        </p:blipFill>
-        <p:spPr>
-          <a:xfrm>
-            <a:off x="10637215" y="228600"/>
-            <a:ext cx="1510270" cy="502920"/>
-          </a:xfrm>
-          <a:prstGeom prst="rect">
-            <a:avLst/>
-          </a:prstGeom>
-        </p:spPr>
-      </p:pic>
-      <p:sp>
-        <p:nvSpPr>
-          <p:cNvPr id="3" name="Rectangle 2"/>
+      <p:sp>
+        <p:nvSpPr>
+          <p:cNvPr id="2" name="Rectangle 1"/>
           <p:cNvSpPr/>
           <p:nvPr/>
         </p:nvSpPr>
@@ -5707,7 +5467,7 @@
       </p:sp>
       <p:sp>
         <p:nvSpPr>
-          <p:cNvPr id="4" name="TextBox 3"/>
+          <p:cNvPr id="3" name="TextBox 2"/>
           <p:cNvSpPr txBox="1"/>
           <p:nvPr/>
         </p:nvSpPr>
@@ -5742,7 +5502,7 @@
       </p:sp>
       <p:sp>
         <p:nvSpPr>
-          <p:cNvPr id="5" name="TextBox 4"/>
+          <p:cNvPr id="4" name="TextBox 3"/>
           <p:cNvSpPr txBox="1"/>
           <p:nvPr/>
         </p:nvSpPr>
@@ -5840,7 +5600,7 @@
       </p:sp>
       <p:sp>
         <p:nvSpPr>
-          <p:cNvPr id="6" name="TextBox 5"/>
+          <p:cNvPr id="5" name="TextBox 4"/>
           <p:cNvSpPr txBox="1"/>
           <p:nvPr/>
         </p:nvSpPr>
@@ -5891,33 +5651,9 @@
         <p:nvPr/>
       </p:nvGrpSpPr>
       <p:grpSpPr/>
-      <p:pic>
-        <p:nvPicPr>
-          <p:cNvPr id="2" name="Picture 1" descr="logoFIUBA.jpg"/>
-          <p:cNvPicPr>
-            <a:picLocks noChangeAspect="1"/>
-          </p:cNvPicPr>
-          <p:nvPr/>
-        </p:nvPicPr>
-        <p:blipFill>
-          <a:blip r:embed="rId2"/>
-          <a:stretch>
-            <a:fillRect/>
-          </a:stretch>
-        </p:blipFill>
-        <p:spPr>
-          <a:xfrm>
-            <a:off x="10637215" y="228600"/>
-            <a:ext cx="1510270" cy="502920"/>
-          </a:xfrm>
-          <a:prstGeom prst="rect">
-            <a:avLst/>
-          </a:prstGeom>
-        </p:spPr>
-      </p:pic>
-      <p:sp>
-        <p:nvSpPr>
-          <p:cNvPr id="3" name="Rectangle 2"/>
+      <p:sp>
+        <p:nvSpPr>
+          <p:cNvPr id="2" name="Rectangle 1"/>
           <p:cNvSpPr/>
           <p:nvPr/>
         </p:nvSpPr>
@@ -5960,7 +5696,7 @@
       </p:sp>
       <p:sp>
         <p:nvSpPr>
-          <p:cNvPr id="4" name="TextBox 3"/>
+          <p:cNvPr id="3" name="TextBox 2"/>
           <p:cNvSpPr txBox="1"/>
           <p:nvPr/>
         </p:nvSpPr>
@@ -5995,7 +5731,7 @@
       </p:sp>
       <p:sp>
         <p:nvSpPr>
-          <p:cNvPr id="5" name="TextBox 4"/>
+          <p:cNvPr id="4" name="TextBox 3"/>
           <p:cNvSpPr txBox="1"/>
           <p:nvPr/>
         </p:nvSpPr>
@@ -6093,7 +5829,7 @@
       </p:sp>
       <p:sp>
         <p:nvSpPr>
-          <p:cNvPr id="6" name="TextBox 5"/>
+          <p:cNvPr id="5" name="TextBox 4"/>
           <p:cNvSpPr txBox="1"/>
           <p:nvPr/>
         </p:nvSpPr>
@@ -6144,33 +5880,9 @@
         <p:nvPr/>
       </p:nvGrpSpPr>
       <p:grpSpPr/>
-      <p:pic>
-        <p:nvPicPr>
-          <p:cNvPr id="2" name="Picture 1" descr="logoFIUBA.jpg"/>
-          <p:cNvPicPr>
-            <a:picLocks noChangeAspect="1"/>
-          </p:cNvPicPr>
-          <p:nvPr/>
-        </p:nvPicPr>
-        <p:blipFill>
-          <a:blip r:embed="rId2"/>
-          <a:stretch>
-            <a:fillRect/>
-          </a:stretch>
-        </p:blipFill>
-        <p:spPr>
-          <a:xfrm>
-            <a:off x="10637215" y="228600"/>
-            <a:ext cx="1510270" cy="502920"/>
-          </a:xfrm>
-          <a:prstGeom prst="rect">
-            <a:avLst/>
-          </a:prstGeom>
-        </p:spPr>
-      </p:pic>
-      <p:sp>
-        <p:nvSpPr>
-          <p:cNvPr id="3" name="Rectangle 2"/>
+      <p:sp>
+        <p:nvSpPr>
+          <p:cNvPr id="2" name="Rectangle 1"/>
           <p:cNvSpPr/>
           <p:nvPr/>
         </p:nvSpPr>
@@ -6213,7 +5925,7 @@
       </p:sp>
       <p:sp>
         <p:nvSpPr>
-          <p:cNvPr id="4" name="TextBox 3"/>
+          <p:cNvPr id="3" name="TextBox 2"/>
           <p:cNvSpPr txBox="1"/>
           <p:nvPr/>
         </p:nvSpPr>
@@ -6260,7 +5972,7 @@
       </p:sp>
       <p:sp>
         <p:nvSpPr>
-          <p:cNvPr id="5" name="TextBox 4"/>
+          <p:cNvPr id="4" name="TextBox 3"/>
           <p:cNvSpPr txBox="1"/>
           <p:nvPr/>
         </p:nvSpPr>
@@ -6403,7 +6115,7 @@
       </p:sp>
       <p:sp>
         <p:nvSpPr>
-          <p:cNvPr id="6" name="TextBox 5"/>
+          <p:cNvPr id="5" name="TextBox 4"/>
           <p:cNvSpPr txBox="1"/>
           <p:nvPr/>
         </p:nvSpPr>
@@ -6454,33 +6166,9 @@
         <p:nvPr/>
       </p:nvGrpSpPr>
       <p:grpSpPr/>
-      <p:pic>
-        <p:nvPicPr>
-          <p:cNvPr id="2" name="Picture 1" descr="logoFIUBA.jpg"/>
-          <p:cNvPicPr>
-            <a:picLocks noChangeAspect="1"/>
-          </p:cNvPicPr>
-          <p:nvPr/>
-        </p:nvPicPr>
-        <p:blipFill>
-          <a:blip r:embed="rId2"/>
-          <a:stretch>
-            <a:fillRect/>
-          </a:stretch>
-        </p:blipFill>
-        <p:spPr>
-          <a:xfrm>
-            <a:off x="10637215" y="228600"/>
-            <a:ext cx="1510270" cy="502920"/>
-          </a:xfrm>
-          <a:prstGeom prst="rect">
-            <a:avLst/>
-          </a:prstGeom>
-        </p:spPr>
-      </p:pic>
-      <p:sp>
-        <p:nvSpPr>
-          <p:cNvPr id="3" name="Rectangle 2"/>
+      <p:sp>
+        <p:nvSpPr>
+          <p:cNvPr id="2" name="Rectangle 1"/>
           <p:cNvSpPr/>
           <p:nvPr/>
         </p:nvSpPr>
@@ -6523,7 +6211,7 @@
       </p:sp>
       <p:sp>
         <p:nvSpPr>
-          <p:cNvPr id="4" name="TextBox 3"/>
+          <p:cNvPr id="3" name="TextBox 2"/>
           <p:cNvSpPr txBox="1"/>
           <p:nvPr/>
         </p:nvSpPr>
@@ -6558,7 +6246,7 @@
       </p:sp>
       <p:sp>
         <p:nvSpPr>
-          <p:cNvPr id="5" name="TextBox 4"/>
+          <p:cNvPr id="4" name="TextBox 3"/>
           <p:cNvSpPr txBox="1"/>
           <p:nvPr/>
         </p:nvSpPr>
@@ -6656,7 +6344,7 @@
       </p:sp>
       <p:sp>
         <p:nvSpPr>
-          <p:cNvPr id="6" name="TextBox 5"/>
+          <p:cNvPr id="5" name="TextBox 4"/>
           <p:cNvSpPr txBox="1"/>
           <p:nvPr/>
         </p:nvSpPr>
@@ -6707,33 +6395,9 @@
         <p:nvPr/>
       </p:nvGrpSpPr>
       <p:grpSpPr/>
-      <p:pic>
-        <p:nvPicPr>
-          <p:cNvPr id="2" name="Picture 1" descr="logoFIUBA.jpg"/>
-          <p:cNvPicPr>
-            <a:picLocks noChangeAspect="1"/>
-          </p:cNvPicPr>
-          <p:nvPr/>
-        </p:nvPicPr>
-        <p:blipFill>
-          <a:blip r:embed="rId2"/>
-          <a:stretch>
-            <a:fillRect/>
-          </a:stretch>
-        </p:blipFill>
-        <p:spPr>
-          <a:xfrm>
-            <a:off x="4937760" y="640080"/>
-            <a:ext cx="2745946" cy="914400"/>
-          </a:xfrm>
-          <a:prstGeom prst="rect">
-            <a:avLst/>
-          </a:prstGeom>
-        </p:spPr>
-      </p:pic>
-      <p:sp>
-        <p:nvSpPr>
-          <p:cNvPr id="3" name="TextBox 2"/>
+      <p:sp>
+        <p:nvSpPr>
+          <p:cNvPr id="2" name="TextBox 1"/>
           <p:cNvSpPr txBox="1"/>
           <p:nvPr/>
         </p:nvSpPr>
@@ -6811,33 +6475,9 @@
         <p:nvPr/>
       </p:nvGrpSpPr>
       <p:grpSpPr/>
-      <p:pic>
-        <p:nvPicPr>
-          <p:cNvPr id="2" name="Picture 1" descr="logoFIUBA.jpg"/>
-          <p:cNvPicPr>
-            <a:picLocks noChangeAspect="1"/>
-          </p:cNvPicPr>
-          <p:nvPr/>
-        </p:nvPicPr>
-        <p:blipFill>
-          <a:blip r:embed="rId2"/>
-          <a:stretch>
-            <a:fillRect/>
-          </a:stretch>
-        </p:blipFill>
-        <p:spPr>
-          <a:xfrm>
-            <a:off x="10637215" y="228600"/>
-            <a:ext cx="1510270" cy="502920"/>
-          </a:xfrm>
-          <a:prstGeom prst="rect">
-            <a:avLst/>
-          </a:prstGeom>
-        </p:spPr>
-      </p:pic>
-      <p:sp>
-        <p:nvSpPr>
-          <p:cNvPr id="3" name="Rectangle 2"/>
+      <p:sp>
+        <p:nvSpPr>
+          <p:cNvPr id="2" name="Rectangle 1"/>
           <p:cNvSpPr/>
           <p:nvPr/>
         </p:nvSpPr>
@@ -6880,7 +6520,7 @@
       </p:sp>
       <p:sp>
         <p:nvSpPr>
-          <p:cNvPr id="4" name="TextBox 3"/>
+          <p:cNvPr id="3" name="TextBox 2"/>
           <p:cNvSpPr txBox="1"/>
           <p:nvPr/>
         </p:nvSpPr>
@@ -6927,7 +6567,7 @@
       </p:sp>
       <p:sp>
         <p:nvSpPr>
-          <p:cNvPr id="5" name="TextBox 4"/>
+          <p:cNvPr id="4" name="TextBox 3"/>
           <p:cNvSpPr txBox="1"/>
           <p:nvPr/>
         </p:nvSpPr>
@@ -7025,7 +6665,7 @@
       </p:sp>
       <p:sp>
         <p:nvSpPr>
-          <p:cNvPr id="6" name="TextBox 5"/>
+          <p:cNvPr id="5" name="TextBox 4"/>
           <p:cNvSpPr txBox="1"/>
           <p:nvPr/>
         </p:nvSpPr>
@@ -7076,33 +6716,9 @@
         <p:nvPr/>
       </p:nvGrpSpPr>
       <p:grpSpPr/>
-      <p:pic>
-        <p:nvPicPr>
-          <p:cNvPr id="2" name="Picture 1" descr="logoFIUBA.jpg"/>
-          <p:cNvPicPr>
-            <a:picLocks noChangeAspect="1"/>
-          </p:cNvPicPr>
-          <p:nvPr/>
-        </p:nvPicPr>
-        <p:blipFill>
-          <a:blip r:embed="rId2"/>
-          <a:stretch>
-            <a:fillRect/>
-          </a:stretch>
-        </p:blipFill>
-        <p:spPr>
-          <a:xfrm>
-            <a:off x="10637215" y="228600"/>
-            <a:ext cx="1510270" cy="502920"/>
-          </a:xfrm>
-          <a:prstGeom prst="rect">
-            <a:avLst/>
-          </a:prstGeom>
-        </p:spPr>
-      </p:pic>
-      <p:sp>
-        <p:nvSpPr>
-          <p:cNvPr id="3" name="Rectangle 2"/>
+      <p:sp>
+        <p:nvSpPr>
+          <p:cNvPr id="2" name="Rectangle 1"/>
           <p:cNvSpPr/>
           <p:nvPr/>
         </p:nvSpPr>
@@ -7145,7 +6761,7 @@
       </p:sp>
       <p:sp>
         <p:nvSpPr>
-          <p:cNvPr id="4" name="TextBox 3"/>
+          <p:cNvPr id="3" name="TextBox 2"/>
           <p:cNvSpPr txBox="1"/>
           <p:nvPr/>
         </p:nvSpPr>
@@ -7180,7 +6796,7 @@
       </p:sp>
       <p:sp>
         <p:nvSpPr>
-          <p:cNvPr id="5" name="TextBox 4"/>
+          <p:cNvPr id="4" name="TextBox 3"/>
           <p:cNvSpPr txBox="1"/>
           <p:nvPr/>
         </p:nvSpPr>
@@ -7278,7 +6894,7 @@
       </p:sp>
       <p:sp>
         <p:nvSpPr>
-          <p:cNvPr id="6" name="TextBox 5"/>
+          <p:cNvPr id="5" name="TextBox 4"/>
           <p:cNvSpPr txBox="1"/>
           <p:nvPr/>
         </p:nvSpPr>
@@ -7329,33 +6945,9 @@
         <p:nvPr/>
       </p:nvGrpSpPr>
       <p:grpSpPr/>
-      <p:pic>
-        <p:nvPicPr>
-          <p:cNvPr id="2" name="Picture 1" descr="logoFIUBA.jpg"/>
-          <p:cNvPicPr>
-            <a:picLocks noChangeAspect="1"/>
-          </p:cNvPicPr>
-          <p:nvPr/>
-        </p:nvPicPr>
-        <p:blipFill>
-          <a:blip r:embed="rId2"/>
-          <a:stretch>
-            <a:fillRect/>
-          </a:stretch>
-        </p:blipFill>
-        <p:spPr>
-          <a:xfrm>
-            <a:off x="10637215" y="228600"/>
-            <a:ext cx="1510270" cy="502920"/>
-          </a:xfrm>
-          <a:prstGeom prst="rect">
-            <a:avLst/>
-          </a:prstGeom>
-        </p:spPr>
-      </p:pic>
-      <p:sp>
-        <p:nvSpPr>
-          <p:cNvPr id="3" name="Rectangle 2"/>
+      <p:sp>
+        <p:nvSpPr>
+          <p:cNvPr id="2" name="Rectangle 1"/>
           <p:cNvSpPr/>
           <p:nvPr/>
         </p:nvSpPr>
@@ -7398,7 +6990,7 @@
       </p:sp>
       <p:sp>
         <p:nvSpPr>
-          <p:cNvPr id="4" name="TextBox 3"/>
+          <p:cNvPr id="3" name="TextBox 2"/>
           <p:cNvSpPr txBox="1"/>
           <p:nvPr/>
         </p:nvSpPr>
@@ -7433,7 +7025,7 @@
       </p:sp>
       <p:sp>
         <p:nvSpPr>
-          <p:cNvPr id="5" name="TextBox 4"/>
+          <p:cNvPr id="4" name="TextBox 3"/>
           <p:cNvSpPr txBox="1"/>
           <p:nvPr/>
         </p:nvSpPr>
@@ -7591,7 +7183,7 @@
       </p:sp>
       <p:sp>
         <p:nvSpPr>
-          <p:cNvPr id="6" name="TextBox 5"/>
+          <p:cNvPr id="5" name="TextBox 4"/>
           <p:cNvSpPr txBox="1"/>
           <p:nvPr/>
         </p:nvSpPr>
@@ -7642,33 +7234,9 @@
         <p:nvPr/>
       </p:nvGrpSpPr>
       <p:grpSpPr/>
-      <p:pic>
-        <p:nvPicPr>
-          <p:cNvPr id="2" name="Picture 1" descr="logoFIUBA.jpg"/>
-          <p:cNvPicPr>
-            <a:picLocks noChangeAspect="1"/>
-          </p:cNvPicPr>
-          <p:nvPr/>
-        </p:nvPicPr>
-        <p:blipFill>
-          <a:blip r:embed="rId2"/>
-          <a:stretch>
-            <a:fillRect/>
-          </a:stretch>
-        </p:blipFill>
-        <p:spPr>
-          <a:xfrm>
-            <a:off x="10637215" y="228600"/>
-            <a:ext cx="1510270" cy="502920"/>
-          </a:xfrm>
-          <a:prstGeom prst="rect">
-            <a:avLst/>
-          </a:prstGeom>
-        </p:spPr>
-      </p:pic>
-      <p:sp>
-        <p:nvSpPr>
-          <p:cNvPr id="3" name="Rectangle 2"/>
+      <p:sp>
+        <p:nvSpPr>
+          <p:cNvPr id="2" name="Rectangle 1"/>
           <p:cNvSpPr/>
           <p:nvPr/>
         </p:nvSpPr>
@@ -7711,7 +7279,7 @@
       </p:sp>
       <p:sp>
         <p:nvSpPr>
-          <p:cNvPr id="4" name="TextBox 3"/>
+          <p:cNvPr id="3" name="TextBox 2"/>
           <p:cNvSpPr txBox="1"/>
           <p:nvPr/>
         </p:nvSpPr>
@@ -7758,7 +7326,7 @@
       </p:sp>
       <p:sp>
         <p:nvSpPr>
-          <p:cNvPr id="5" name="TextBox 4"/>
+          <p:cNvPr id="4" name="TextBox 3"/>
           <p:cNvSpPr txBox="1"/>
           <p:nvPr/>
         </p:nvSpPr>
@@ -7871,7 +7439,7 @@
       </p:sp>
       <p:sp>
         <p:nvSpPr>
-          <p:cNvPr id="6" name="TextBox 5"/>
+          <p:cNvPr id="5" name="TextBox 4"/>
           <p:cNvSpPr txBox="1"/>
           <p:nvPr/>
         </p:nvSpPr>
@@ -7922,33 +7490,9 @@
         <p:nvPr/>
       </p:nvGrpSpPr>
       <p:grpSpPr/>
-      <p:pic>
-        <p:nvPicPr>
-          <p:cNvPr id="2" name="Picture 1" descr="logoFIUBA.jpg"/>
-          <p:cNvPicPr>
-            <a:picLocks noChangeAspect="1"/>
-          </p:cNvPicPr>
-          <p:nvPr/>
-        </p:nvPicPr>
-        <p:blipFill>
-          <a:blip r:embed="rId2"/>
-          <a:stretch>
-            <a:fillRect/>
-          </a:stretch>
-        </p:blipFill>
-        <p:spPr>
-          <a:xfrm>
-            <a:off x="10637215" y="228600"/>
-            <a:ext cx="1510270" cy="502920"/>
-          </a:xfrm>
-          <a:prstGeom prst="rect">
-            <a:avLst/>
-          </a:prstGeom>
-        </p:spPr>
-      </p:pic>
-      <p:sp>
-        <p:nvSpPr>
-          <p:cNvPr id="3" name="Rectangle 2"/>
+      <p:sp>
+        <p:nvSpPr>
+          <p:cNvPr id="2" name="Rectangle 1"/>
           <p:cNvSpPr/>
           <p:nvPr/>
         </p:nvSpPr>
@@ -7991,7 +7535,7 @@
       </p:sp>
       <p:sp>
         <p:nvSpPr>
-          <p:cNvPr id="4" name="TextBox 3"/>
+          <p:cNvPr id="3" name="TextBox 2"/>
           <p:cNvSpPr txBox="1"/>
           <p:nvPr/>
         </p:nvSpPr>
@@ -8026,7 +7570,7 @@
       </p:sp>
       <p:sp>
         <p:nvSpPr>
-          <p:cNvPr id="5" name="TextBox 4"/>
+          <p:cNvPr id="4" name="TextBox 3"/>
           <p:cNvSpPr txBox="1"/>
           <p:nvPr/>
         </p:nvSpPr>
@@ -8124,7 +7668,7 @@
       </p:sp>
       <p:sp>
         <p:nvSpPr>
-          <p:cNvPr id="6" name="TextBox 5"/>
+          <p:cNvPr id="5" name="TextBox 4"/>
           <p:cNvSpPr txBox="1"/>
           <p:nvPr/>
         </p:nvSpPr>
@@ -8175,33 +7719,9 @@
         <p:nvPr/>
       </p:nvGrpSpPr>
       <p:grpSpPr/>
-      <p:pic>
-        <p:nvPicPr>
-          <p:cNvPr id="2" name="Picture 1" descr="logoFIUBA.jpg"/>
-          <p:cNvPicPr>
-            <a:picLocks noChangeAspect="1"/>
-          </p:cNvPicPr>
-          <p:nvPr/>
-        </p:nvPicPr>
-        <p:blipFill>
-          <a:blip r:embed="rId2"/>
-          <a:stretch>
-            <a:fillRect/>
-          </a:stretch>
-        </p:blipFill>
-        <p:spPr>
-          <a:xfrm>
-            <a:off x="10637215" y="228600"/>
-            <a:ext cx="1510270" cy="502920"/>
-          </a:xfrm>
-          <a:prstGeom prst="rect">
-            <a:avLst/>
-          </a:prstGeom>
-        </p:spPr>
-      </p:pic>
-      <p:sp>
-        <p:nvSpPr>
-          <p:cNvPr id="3" name="Rectangle 2"/>
+      <p:sp>
+        <p:nvSpPr>
+          <p:cNvPr id="2" name="Rectangle 1"/>
           <p:cNvSpPr/>
           <p:nvPr/>
         </p:nvSpPr>
@@ -8244,7 +7764,7 @@
       </p:sp>
       <p:sp>
         <p:nvSpPr>
-          <p:cNvPr id="4" name="TextBox 3"/>
+          <p:cNvPr id="3" name="TextBox 2"/>
           <p:cNvSpPr txBox="1"/>
           <p:nvPr/>
         </p:nvSpPr>
@@ -8291,7 +7811,7 @@
       </p:sp>
       <p:sp>
         <p:nvSpPr>
-          <p:cNvPr id="5" name="TextBox 4"/>
+          <p:cNvPr id="4" name="TextBox 3"/>
           <p:cNvSpPr txBox="1"/>
           <p:nvPr/>
         </p:nvSpPr>
@@ -8419,7 +7939,7 @@
       </p:sp>
       <p:sp>
         <p:nvSpPr>
-          <p:cNvPr id="6" name="TextBox 5"/>
+          <p:cNvPr id="5" name="TextBox 4"/>
           <p:cNvSpPr txBox="1"/>
           <p:nvPr/>
         </p:nvSpPr>
@@ -8470,33 +7990,9 @@
         <p:nvPr/>
       </p:nvGrpSpPr>
       <p:grpSpPr/>
-      <p:pic>
-        <p:nvPicPr>
-          <p:cNvPr id="2" name="Picture 1" descr="logoFIUBA.jpg"/>
-          <p:cNvPicPr>
-            <a:picLocks noChangeAspect="1"/>
-          </p:cNvPicPr>
-          <p:nvPr/>
-        </p:nvPicPr>
-        <p:blipFill>
-          <a:blip r:embed="rId2"/>
-          <a:stretch>
-            <a:fillRect/>
-          </a:stretch>
-        </p:blipFill>
-        <p:spPr>
-          <a:xfrm>
-            <a:off x="10637215" y="228600"/>
-            <a:ext cx="1510270" cy="502920"/>
-          </a:xfrm>
-          <a:prstGeom prst="rect">
-            <a:avLst/>
-          </a:prstGeom>
-        </p:spPr>
-      </p:pic>
-      <p:sp>
-        <p:nvSpPr>
-          <p:cNvPr id="3" name="Rectangle 2"/>
+      <p:sp>
+        <p:nvSpPr>
+          <p:cNvPr id="2" name="Rectangle 1"/>
           <p:cNvSpPr/>
           <p:nvPr/>
         </p:nvSpPr>
@@ -8539,7 +8035,7 @@
       </p:sp>
       <p:sp>
         <p:nvSpPr>
-          <p:cNvPr id="4" name="TextBox 3"/>
+          <p:cNvPr id="3" name="TextBox 2"/>
           <p:cNvSpPr txBox="1"/>
           <p:nvPr/>
         </p:nvSpPr>
@@ -8574,7 +8070,7 @@
       </p:sp>
       <p:sp>
         <p:nvSpPr>
-          <p:cNvPr id="5" name="TextBox 4"/>
+          <p:cNvPr id="4" name="TextBox 3"/>
           <p:cNvSpPr txBox="1"/>
           <p:nvPr/>
         </p:nvSpPr>
@@ -8687,7 +8183,7 @@
       </p:sp>
       <p:sp>
         <p:nvSpPr>
-          <p:cNvPr id="6" name="TextBox 5"/>
+          <p:cNvPr id="5" name="TextBox 4"/>
           <p:cNvSpPr txBox="1"/>
           <p:nvPr/>
         </p:nvSpPr>

</xml_diff>